<commit_message>
Remove temporary diagnostic scripts
</commit_message>
<xml_diff>
--- a/documentation/Data_Validation_Tool_Overview.pptx
+++ b/documentation/Data_Validation_Tool_Overview.pptx
@@ -4621,7 +4621,7 @@
           <a:p>
             <a:fld id="{5BCAD085-E8A6-8845-BD4E-CB4CCA059FC4}" type="datetimeFigureOut">
               <a:rPr lang="en-US" smtClean="0"/>
-              <a:t>8/8/2025</a:t>
+              <a:t>9/11/2025</a:t>
             </a:fld>
             <a:endParaRPr lang="en-US"/>
           </a:p>
@@ -4789,7 +4789,7 @@
           <a:p>
             <a:fld id="{5BCAD085-E8A6-8845-BD4E-CB4CCA059FC4}" type="datetimeFigureOut">
               <a:rPr lang="en-US" smtClean="0"/>
-              <a:t>8/8/2025</a:t>
+              <a:t>9/11/2025</a:t>
             </a:fld>
             <a:endParaRPr lang="en-US"/>
           </a:p>
@@ -4967,7 +4967,7 @@
           <a:p>
             <a:fld id="{5BCAD085-E8A6-8845-BD4E-CB4CCA059FC4}" type="datetimeFigureOut">
               <a:rPr lang="en-US" smtClean="0"/>
-              <a:t>8/8/2025</a:t>
+              <a:t>9/11/2025</a:t>
             </a:fld>
             <a:endParaRPr lang="en-US"/>
           </a:p>
@@ -5135,7 +5135,7 @@
           <a:p>
             <a:fld id="{5BCAD085-E8A6-8845-BD4E-CB4CCA059FC4}" type="datetimeFigureOut">
               <a:rPr lang="en-US" smtClean="0"/>
-              <a:t>8/8/2025</a:t>
+              <a:t>9/11/2025</a:t>
             </a:fld>
             <a:endParaRPr lang="en-US"/>
           </a:p>
@@ -5380,7 +5380,7 @@
           <a:p>
             <a:fld id="{5BCAD085-E8A6-8845-BD4E-CB4CCA059FC4}" type="datetimeFigureOut">
               <a:rPr lang="en-US" smtClean="0"/>
-              <a:t>8/8/2025</a:t>
+              <a:t>9/11/2025</a:t>
             </a:fld>
             <a:endParaRPr lang="en-US"/>
           </a:p>
@@ -5665,7 +5665,7 @@
           <a:p>
             <a:fld id="{5BCAD085-E8A6-8845-BD4E-CB4CCA059FC4}" type="datetimeFigureOut">
               <a:rPr lang="en-US" smtClean="0"/>
-              <a:t>8/8/2025</a:t>
+              <a:t>9/11/2025</a:t>
             </a:fld>
             <a:endParaRPr lang="en-US"/>
           </a:p>
@@ -6084,7 +6084,7 @@
           <a:p>
             <a:fld id="{5BCAD085-E8A6-8845-BD4E-CB4CCA059FC4}" type="datetimeFigureOut">
               <a:rPr lang="en-US" smtClean="0"/>
-              <a:t>8/8/2025</a:t>
+              <a:t>9/11/2025</a:t>
             </a:fld>
             <a:endParaRPr lang="en-US"/>
           </a:p>
@@ -6201,7 +6201,7 @@
           <a:p>
             <a:fld id="{5BCAD085-E8A6-8845-BD4E-CB4CCA059FC4}" type="datetimeFigureOut">
               <a:rPr lang="en-US" smtClean="0"/>
-              <a:t>8/8/2025</a:t>
+              <a:t>9/11/2025</a:t>
             </a:fld>
             <a:endParaRPr lang="en-US"/>
           </a:p>
@@ -6296,7 +6296,7 @@
           <a:p>
             <a:fld id="{5BCAD085-E8A6-8845-BD4E-CB4CCA059FC4}" type="datetimeFigureOut">
               <a:rPr lang="en-US" smtClean="0"/>
-              <a:t>8/8/2025</a:t>
+              <a:t>9/11/2025</a:t>
             </a:fld>
             <a:endParaRPr lang="en-US"/>
           </a:p>
@@ -6571,7 +6571,7 @@
           <a:p>
             <a:fld id="{5BCAD085-E8A6-8845-BD4E-CB4CCA059FC4}" type="datetimeFigureOut">
               <a:rPr lang="en-US" smtClean="0"/>
-              <a:t>8/8/2025</a:t>
+              <a:t>9/11/2025</a:t>
             </a:fld>
             <a:endParaRPr lang="en-US"/>
           </a:p>
@@ -6823,7 +6823,7 @@
           <a:p>
             <a:fld id="{5BCAD085-E8A6-8845-BD4E-CB4CCA059FC4}" type="datetimeFigureOut">
               <a:rPr lang="en-US" smtClean="0"/>
-              <a:t>8/8/2025</a:t>
+              <a:t>9/11/2025</a:t>
             </a:fld>
             <a:endParaRPr lang="en-US"/>
           </a:p>
@@ -7034,7 +7034,7 @@
           <a:p>
             <a:fld id="{5BCAD085-E8A6-8845-BD4E-CB4CCA059FC4}" type="datetimeFigureOut">
               <a:rPr lang="en-US" smtClean="0"/>
-              <a:t>8/8/2025</a:t>
+              <a:t>9/11/2025</a:t>
             </a:fld>
             <a:endParaRPr lang="en-US"/>
           </a:p>
@@ -12568,7 +12568,7 @@
             <a:pPr algn="ctr"/>
             <a:r>
               <a:rPr lang="en-US" dirty="0"/>
-              <a:t>User Input (CLI/GUI) → Configuration Management → Data Sources (CSV/Excel)</a:t>
+              <a:t>User Input (CLI/GUI) → Configuration Management → Data Sources (CSV/Excel/Json)</a:t>
             </a:r>
           </a:p>
           <a:p>
@@ -13198,21 +13198,12 @@
             </a:pPr>
             <a:r>
               <a:rPr dirty="0"/>
-              <a:t>   • Detailed reporting</a:t>
-            </a:r>
-          </a:p>
-          <a:p>
-            <a:pPr>
-              <a:defRPr sz="1800">
-                <a:solidFill>
-                  <a:srgbClr val="424242"/>
-                </a:solidFill>
-              </a:defRPr>
-            </a:pPr>
-            <a:r>
-              <a:rPr dirty="0"/>
-              <a:t>   • Visual analytics</a:t>
-            </a:r>
+              <a:t>   • </a:t>
+            </a:r>
+            <a:r>
+              <a:t>Detailed reporting</a:t>
+            </a:r>
+            <a:endParaRPr dirty="0"/>
           </a:p>
         </p:txBody>
       </p:sp>

</xml_diff>